<commit_message>
How It Works thumbnails v2: six hero plants, 45% soil band, large organisms, Montserrat Bold, layered PowerPoint
Co-Authored-By: Claude Opus 5.5 <noreply@anthropic.com>
Claude-Session: https://claude.ai/code/session_01987b9uQ2CUkrkGTD4NN5Cd
</commit_message>
<xml_diff>
--- a/exports/stephanie/how-it-works/how-it-works-thumbnails.pptx
+++ b/exports/stephanie/how-it-works/how-it-works-thumbnails.pptx
@@ -3573,8 +3573,8 @@
         </p:blipFill>
         <p:spPr>
           <a:xfrm>
-            <a:off x="0" y="1949450"/>
-            <a:ext cx="12192000" cy="4908550"/>
+            <a:off x="0" y="1943100"/>
+            <a:ext cx="12192000" cy="4914900"/>
           </a:xfrm>
           <a:prstGeom prst="rect">
             <a:avLst/>
@@ -3597,8 +3597,8 @@
         </p:blipFill>
         <p:spPr>
           <a:xfrm>
-            <a:off x="5810250" y="4679950"/>
-            <a:ext cx="787400" cy="2178050"/>
+            <a:off x="5651500" y="4470400"/>
+            <a:ext cx="1016000" cy="2387600"/>
           </a:xfrm>
           <a:prstGeom prst="rect">
             <a:avLst/>
@@ -3622,7 +3622,7 @@
         <p:spPr>
           <a:xfrm>
             <a:off x="977900" y="546100"/>
-            <a:ext cx="1206500" cy="1051655"/>
+            <a:ext cx="1460500" cy="1273056"/>
           </a:xfrm>
           <a:prstGeom prst="rect">
             <a:avLst/>
@@ -3637,8 +3637,8 @@
         </p:nvSpPr>
         <p:spPr>
           <a:xfrm>
-            <a:off x="6350000" y="590550"/>
-            <a:ext cx="4864100" cy="1397000"/>
+            <a:off x="4953000" y="565150"/>
+            <a:ext cx="6261100" cy="1524000"/>
           </a:xfrm>
           <a:prstGeom prst="rect">
             <a:avLst/>
@@ -3646,18 +3646,18 @@
           <a:noFill/>
         </p:spPr>
         <p:txBody>
-          <a:bodyPr wrap="square" lIns="0" rIns="0" tIns="0" bIns="0" anchor="t">
+          <a:bodyPr wrap="none" lIns="0" rIns="0" tIns="0" bIns="0" anchor="t">
             <a:spAutoFit/>
           </a:bodyPr>
           <a:lstStyle/>
           <a:p>
             <a:pPr algn="r">
               <a:lnSpc>
-                <a:spcPts val="4600"/>
+                <a:spcPts val="5200"/>
               </a:lnSpc>
             </a:pPr>
             <a:r>
-              <a:rPr b="1" sz="4100">
+              <a:rPr b="1" sz="4700">
                 <a:solidFill>
                   <a:srgbClr val="FFFFFF"/>
                 </a:solidFill>
@@ -3669,11 +3669,11 @@
           <a:p>
             <a:pPr algn="r">
               <a:lnSpc>
-                <a:spcPts val="4600"/>
+                <a:spcPts val="5200"/>
               </a:lnSpc>
             </a:pPr>
             <a:r>
-              <a:rPr b="1" sz="4100">
+              <a:rPr b="1" sz="4700">
                 <a:solidFill>
                   <a:srgbClr val="FFFFFF"/>
                 </a:solidFill>
@@ -4182,8 +4182,8 @@
         </p:blipFill>
         <p:spPr>
           <a:xfrm>
-            <a:off x="0" y="1949450"/>
-            <a:ext cx="12192000" cy="4908550"/>
+            <a:off x="0" y="2019300"/>
+            <a:ext cx="12192000" cy="4838700"/>
           </a:xfrm>
           <a:prstGeom prst="rect">
             <a:avLst/>
@@ -4206,8 +4206,8 @@
         </p:blipFill>
         <p:spPr>
           <a:xfrm>
-            <a:off x="5810250" y="4679950"/>
-            <a:ext cx="787400" cy="2178050"/>
+            <a:off x="5651500" y="4470400"/>
+            <a:ext cx="1016000" cy="2387600"/>
           </a:xfrm>
           <a:prstGeom prst="rect">
             <a:avLst/>
@@ -4231,7 +4231,7 @@
         <p:spPr>
           <a:xfrm>
             <a:off x="977900" y="546100"/>
-            <a:ext cx="1206500" cy="1051655"/>
+            <a:ext cx="1460500" cy="1273056"/>
           </a:xfrm>
           <a:prstGeom prst="rect">
             <a:avLst/>
@@ -4246,8 +4246,8 @@
         </p:nvSpPr>
         <p:spPr>
           <a:xfrm>
-            <a:off x="6350000" y="590550"/>
-            <a:ext cx="4864100" cy="1397000"/>
+            <a:off x="4953000" y="565150"/>
+            <a:ext cx="6261100" cy="1524000"/>
           </a:xfrm>
           <a:prstGeom prst="rect">
             <a:avLst/>
@@ -4255,18 +4255,18 @@
           <a:noFill/>
         </p:spPr>
         <p:txBody>
-          <a:bodyPr wrap="square" lIns="0" rIns="0" tIns="0" bIns="0" anchor="t">
+          <a:bodyPr wrap="none" lIns="0" rIns="0" tIns="0" bIns="0" anchor="t">
             <a:spAutoFit/>
           </a:bodyPr>
           <a:lstStyle/>
           <a:p>
             <a:pPr algn="r">
               <a:lnSpc>
-                <a:spcPts val="4600"/>
+                <a:spcPts val="5200"/>
               </a:lnSpc>
             </a:pPr>
             <a:r>
-              <a:rPr b="1" sz="4100">
+              <a:rPr b="1" sz="4700">
                 <a:solidFill>
                   <a:srgbClr val="FFFFFF"/>
                 </a:solidFill>
@@ -4278,11 +4278,11 @@
           <a:p>
             <a:pPr algn="r">
               <a:lnSpc>
-                <a:spcPts val="4600"/>
+                <a:spcPts val="5200"/>
               </a:lnSpc>
             </a:pPr>
             <a:r>
-              <a:rPr b="1" sz="4100">
+              <a:rPr b="1" sz="4700">
                 <a:solidFill>
                   <a:srgbClr val="FFFFFF"/>
                 </a:solidFill>
@@ -4791,8 +4791,8 @@
         </p:blipFill>
         <p:spPr>
           <a:xfrm>
-            <a:off x="0" y="1949450"/>
-            <a:ext cx="12192000" cy="4908550"/>
+            <a:off x="0" y="1943100"/>
+            <a:ext cx="12192000" cy="4914900"/>
           </a:xfrm>
           <a:prstGeom prst="rect">
             <a:avLst/>
@@ -4815,8 +4815,8 @@
         </p:blipFill>
         <p:spPr>
           <a:xfrm>
-            <a:off x="5810250" y="4679950"/>
-            <a:ext cx="787400" cy="2178050"/>
+            <a:off x="5651500" y="4470400"/>
+            <a:ext cx="1016000" cy="2387600"/>
           </a:xfrm>
           <a:prstGeom prst="rect">
             <a:avLst/>
@@ -4840,7 +4840,7 @@
         <p:spPr>
           <a:xfrm>
             <a:off x="977900" y="546100"/>
-            <a:ext cx="1206500" cy="1051655"/>
+            <a:ext cx="1460500" cy="1273056"/>
           </a:xfrm>
           <a:prstGeom prst="rect">
             <a:avLst/>
@@ -4855,8 +4855,8 @@
         </p:nvSpPr>
         <p:spPr>
           <a:xfrm>
-            <a:off x="6350000" y="590550"/>
-            <a:ext cx="4864100" cy="1397000"/>
+            <a:off x="4953000" y="565150"/>
+            <a:ext cx="6261100" cy="1524000"/>
           </a:xfrm>
           <a:prstGeom prst="rect">
             <a:avLst/>
@@ -4864,18 +4864,18 @@
           <a:noFill/>
         </p:spPr>
         <p:txBody>
-          <a:bodyPr wrap="square" lIns="0" rIns="0" tIns="0" bIns="0" anchor="t">
+          <a:bodyPr wrap="none" lIns="0" rIns="0" tIns="0" bIns="0" anchor="t">
             <a:spAutoFit/>
           </a:bodyPr>
           <a:lstStyle/>
           <a:p>
             <a:pPr algn="r">
               <a:lnSpc>
-                <a:spcPts val="4600"/>
+                <a:spcPts val="5200"/>
               </a:lnSpc>
             </a:pPr>
             <a:r>
-              <a:rPr b="1" sz="4100">
+              <a:rPr b="1" sz="4700">
                 <a:solidFill>
                   <a:srgbClr val="FFFFFF"/>
                 </a:solidFill>
@@ -4887,11 +4887,11 @@
           <a:p>
             <a:pPr algn="r">
               <a:lnSpc>
-                <a:spcPts val="4600"/>
+                <a:spcPts val="5200"/>
               </a:lnSpc>
             </a:pPr>
             <a:r>
-              <a:rPr b="1" sz="4100">
+              <a:rPr b="1" sz="4700">
                 <a:solidFill>
                   <a:srgbClr val="FFFFFF"/>
                 </a:solidFill>
@@ -5400,8 +5400,8 @@
         </p:blipFill>
         <p:spPr>
           <a:xfrm>
-            <a:off x="0" y="1517650"/>
-            <a:ext cx="12192000" cy="5340350"/>
+            <a:off x="0" y="1892300"/>
+            <a:ext cx="12192000" cy="4965700"/>
           </a:xfrm>
           <a:prstGeom prst="rect">
             <a:avLst/>
@@ -5424,8 +5424,8 @@
         </p:blipFill>
         <p:spPr>
           <a:xfrm>
-            <a:off x="5810250" y="4679950"/>
-            <a:ext cx="787400" cy="2178050"/>
+            <a:off x="5651500" y="4470400"/>
+            <a:ext cx="1016000" cy="2387600"/>
           </a:xfrm>
           <a:prstGeom prst="rect">
             <a:avLst/>
@@ -5449,7 +5449,7 @@
         <p:spPr>
           <a:xfrm>
             <a:off x="977900" y="546100"/>
-            <a:ext cx="1206500" cy="1051655"/>
+            <a:ext cx="1460500" cy="1273056"/>
           </a:xfrm>
           <a:prstGeom prst="rect">
             <a:avLst/>
@@ -5464,8 +5464,8 @@
         </p:nvSpPr>
         <p:spPr>
           <a:xfrm>
-            <a:off x="6350000" y="590550"/>
-            <a:ext cx="4864100" cy="1397000"/>
+            <a:off x="4953000" y="565150"/>
+            <a:ext cx="6261100" cy="1524000"/>
           </a:xfrm>
           <a:prstGeom prst="rect">
             <a:avLst/>
@@ -5473,18 +5473,18 @@
           <a:noFill/>
         </p:spPr>
         <p:txBody>
-          <a:bodyPr wrap="square" lIns="0" rIns="0" tIns="0" bIns="0" anchor="t">
+          <a:bodyPr wrap="none" lIns="0" rIns="0" tIns="0" bIns="0" anchor="t">
             <a:spAutoFit/>
           </a:bodyPr>
           <a:lstStyle/>
           <a:p>
             <a:pPr algn="r">
               <a:lnSpc>
-                <a:spcPts val="4600"/>
+                <a:spcPts val="5200"/>
               </a:lnSpc>
             </a:pPr>
             <a:r>
-              <a:rPr b="1" sz="4100">
+              <a:rPr b="1" sz="4700">
                 <a:solidFill>
                   <a:srgbClr val="FFFFFF"/>
                 </a:solidFill>
@@ -5496,11 +5496,11 @@
           <a:p>
             <a:pPr algn="r">
               <a:lnSpc>
-                <a:spcPts val="4600"/>
+                <a:spcPts val="5200"/>
               </a:lnSpc>
             </a:pPr>
             <a:r>
-              <a:rPr b="1" sz="4100">
+              <a:rPr b="1" sz="4700">
                 <a:solidFill>
                   <a:srgbClr val="FFFFFF"/>
                 </a:solidFill>
@@ -6009,8 +6009,8 @@
         </p:blipFill>
         <p:spPr>
           <a:xfrm>
-            <a:off x="0" y="1949450"/>
-            <a:ext cx="12192000" cy="4908550"/>
+            <a:off x="0" y="1943100"/>
+            <a:ext cx="12192000" cy="4914900"/>
           </a:xfrm>
           <a:prstGeom prst="rect">
             <a:avLst/>
@@ -6033,8 +6033,8 @@
         </p:blipFill>
         <p:spPr>
           <a:xfrm>
-            <a:off x="5810250" y="4679950"/>
-            <a:ext cx="787400" cy="2178050"/>
+            <a:off x="5651500" y="4470400"/>
+            <a:ext cx="1016000" cy="2387600"/>
           </a:xfrm>
           <a:prstGeom prst="rect">
             <a:avLst/>
@@ -6058,7 +6058,7 @@
         <p:spPr>
           <a:xfrm>
             <a:off x="977900" y="546100"/>
-            <a:ext cx="1206500" cy="1051655"/>
+            <a:ext cx="1460500" cy="1273056"/>
           </a:xfrm>
           <a:prstGeom prst="rect">
             <a:avLst/>
@@ -6073,8 +6073,8 @@
         </p:nvSpPr>
         <p:spPr>
           <a:xfrm>
-            <a:off x="6350000" y="590550"/>
-            <a:ext cx="4864100" cy="1397000"/>
+            <a:off x="4953000" y="565150"/>
+            <a:ext cx="6261100" cy="1524000"/>
           </a:xfrm>
           <a:prstGeom prst="rect">
             <a:avLst/>
@@ -6082,18 +6082,18 @@
           <a:noFill/>
         </p:spPr>
         <p:txBody>
-          <a:bodyPr wrap="square" lIns="0" rIns="0" tIns="0" bIns="0" anchor="t">
+          <a:bodyPr wrap="none" lIns="0" rIns="0" tIns="0" bIns="0" anchor="t">
             <a:spAutoFit/>
           </a:bodyPr>
           <a:lstStyle/>
           <a:p>
             <a:pPr algn="r">
               <a:lnSpc>
-                <a:spcPts val="4600"/>
+                <a:spcPts val="5200"/>
               </a:lnSpc>
             </a:pPr>
             <a:r>
-              <a:rPr b="1" sz="4100">
+              <a:rPr b="1" sz="4700">
                 <a:solidFill>
                   <a:srgbClr val="FFFFFF"/>
                 </a:solidFill>
@@ -6105,11 +6105,11 @@
           <a:p>
             <a:pPr algn="r">
               <a:lnSpc>
-                <a:spcPts val="4600"/>
+                <a:spcPts val="5200"/>
               </a:lnSpc>
             </a:pPr>
             <a:r>
-              <a:rPr b="1" sz="4100">
+              <a:rPr b="1" sz="4700">
                 <a:solidFill>
                   <a:srgbClr val="FFFFFF"/>
                 </a:solidFill>
@@ -6618,8 +6618,8 @@
         </p:blipFill>
         <p:spPr>
           <a:xfrm>
-            <a:off x="0" y="1949450"/>
-            <a:ext cx="12192000" cy="4908550"/>
+            <a:off x="0" y="1943100"/>
+            <a:ext cx="12192000" cy="4914900"/>
           </a:xfrm>
           <a:prstGeom prst="rect">
             <a:avLst/>
@@ -6642,8 +6642,8 @@
         </p:blipFill>
         <p:spPr>
           <a:xfrm>
-            <a:off x="5810250" y="4679950"/>
-            <a:ext cx="787400" cy="2178050"/>
+            <a:off x="5651500" y="4470400"/>
+            <a:ext cx="1016000" cy="2387600"/>
           </a:xfrm>
           <a:prstGeom prst="rect">
             <a:avLst/>
@@ -6667,7 +6667,7 @@
         <p:spPr>
           <a:xfrm>
             <a:off x="977900" y="546100"/>
-            <a:ext cx="1206500" cy="1051655"/>
+            <a:ext cx="1460500" cy="1273056"/>
           </a:xfrm>
           <a:prstGeom prst="rect">
             <a:avLst/>
@@ -6682,8 +6682,8 @@
         </p:nvSpPr>
         <p:spPr>
           <a:xfrm>
-            <a:off x="6350000" y="590550"/>
-            <a:ext cx="4864100" cy="1397000"/>
+            <a:off x="4953000" y="565150"/>
+            <a:ext cx="6261100" cy="1524000"/>
           </a:xfrm>
           <a:prstGeom prst="rect">
             <a:avLst/>
@@ -6691,18 +6691,18 @@
           <a:noFill/>
         </p:spPr>
         <p:txBody>
-          <a:bodyPr wrap="square" lIns="0" rIns="0" tIns="0" bIns="0" anchor="t">
+          <a:bodyPr wrap="none" lIns="0" rIns="0" tIns="0" bIns="0" anchor="t">
             <a:spAutoFit/>
           </a:bodyPr>
           <a:lstStyle/>
           <a:p>
             <a:pPr algn="r">
               <a:lnSpc>
-                <a:spcPts val="4600"/>
+                <a:spcPts val="5200"/>
               </a:lnSpc>
             </a:pPr>
             <a:r>
-              <a:rPr b="1" sz="4100">
+              <a:rPr b="1" sz="4700">
                 <a:solidFill>
                   <a:srgbClr val="FFFFFF"/>
                 </a:solidFill>
@@ -6714,11 +6714,11 @@
           <a:p>
             <a:pPr algn="r">
               <a:lnSpc>
-                <a:spcPts val="4600"/>
+                <a:spcPts val="5200"/>
               </a:lnSpc>
             </a:pPr>
             <a:r>
-              <a:rPr b="1" sz="4100">
+              <a:rPr b="1" sz="4700">
                 <a:solidFill>
                   <a:srgbClr val="FFFFFF"/>
                 </a:solidFill>

</xml_diff>